<commit_message>
Reorganiza a documentação de construção
Os três documentos de briefing saíram de docs/prompts para docs/briefing, com as
aberturas reescritas: descrevem as partes do briefing em vez de se apresentarem
como material de entrada. As referências ao caminho antigo foram acertadas nos
READMEs, planos e comentários de código.

As instruções locais de ferramenta deixam de ser versionadas: continuam no disco
de quem constrói, mas fora do repositório público.
</commit_message>
<xml_diff>
--- a/docs/decks/multiagente-docs.pptx
+++ b/docs/decks/multiagente-docs.pptx
@@ -502,7 +502,7 @@
           <a:p>
             <a:r>
               <a:rPr lang="en-US" dirty="0"/>
-              <a:t>A documentação do PoV é dividida por leitor: README para o cliente, CLAUDE.md/AGENTS.md para o assistente de código, implementation_plan.md para quem reconstrói, architecture.md e ADR-001 para o arquiteto. Faltam runbook de demo, modelo de dados, ADRs novos e SECURITY.md.</a:t>
+              <a:t>A documentação do PoV é dividida por leitor: README para o cliente, o briefing de arquitetura para quem constrói, implementation_plan.md para quem reconstrói, architecture.md e ADR-001 para o arquiteto. Faltam runbook de demo, modelo de dados, ADRs novos e SECURITY.md.</a:t>
             </a:r>
             <a:endParaRPr lang="en-US" dirty="0"/>
           </a:p>
@@ -1310,7 +1310,7 @@
                 <a:ea typeface="Courier New" pitchFamily="34" charset="-122"/>
                 <a:cs typeface="Courier New" pitchFamily="34" charset="-120"/>
               </a:rPr>
-              <a:t>├── CLAUDE.md</a:t>
+              <a:t>├── briefing de arquitetura</a:t>
             </a:r>
             <a:endParaRPr lang="en-US" sz="900" dirty="0"/>
           </a:p>
@@ -1388,7 +1388,7 @@
                 <a:ea typeface="Courier New" pitchFamily="34" charset="-122"/>
                 <a:cs typeface="Courier New" pitchFamily="34" charset="-120"/>
               </a:rPr>
-              <a:t>├── AGENTS.md</a:t>
+              <a:t>├── briefing de arquitetura</a:t>
             </a:r>
             <a:endParaRPr lang="en-US" sz="900" dirty="0"/>
           </a:p>
@@ -2298,7 +2298,7 @@
                 <a:ea typeface="Calibri" pitchFamily="34" charset="-122"/>
                 <a:cs typeface="Calibri" pitchFamily="34" charset="-120"/>
               </a:rPr>
-              <a:t>2 · CLAUDE.md / AGENTS.md</a:t>
+              <a:t>2 · briefing de arquitetura</a:t>
             </a:r>
             <a:endParaRPr lang="en-US" sz="1050" dirty="0"/>
           </a:p>

</xml_diff>